<commit_message>
Prepara a retomada com acesso de rede liberado
- CLAUDE.md: contexto do trabalho, estado atual, próximos passos em ordem e a
  regra de que nenhum número entra nos documentos sem ter sido medido. A sessão
  nova nasce sabendo disso sem precisar reconstruir o histórico.

- ferramenta/avaliar.sh: roda a avaliação inteira num comando — confere se a
  rede alcança o site, audita as páginas, simula o acesso por smartphone e
  regera os documentos. Falha cedo, com mensagem clara, quando o domínio ainda
  não está liberado.

- simulador_mobile.py passa a contar os recursos que não carregam (CSS, fontes,
  scripts, imagens). Um CDN bloqueado fazia a página ser medida sem a aparência
  real, e contraste e reflow saíam errados sem qualquer aviso. Agora a saída
  nomeia os domínios envolvidos e marca a medição como não confiável.

Co-Authored-By: Claude Opus 5 <noreply@anthropic.com>
Claude-Session: https://claude.ai/code/session_01P7CQ66uwaiuJDfW2UoBWp1
</commit_message>
<xml_diff>
--- a/apresentacao/APRESENTACAO_AVALIACAO_ACESSIBILIDADE.pptx
+++ b/apresentacao/APRESENTACAO_AVALIACAO_ACESSIBILIDADE.pptx
@@ -14135,7 +14135,7 @@
               <a:rPr sz="1500">
                 <a:latin typeface="Arial"/>
               </a:rPr>
-              <a:t>6. Cor não e o único meio de transmitir informação — 1.4.1 (A): </a:t>
+              <a:t>6. Cor não é o único meio de transmitir informação — 1.4.1 (A): </a:t>
             </a:r>
             <a:r>
               <a:rPr sz="1500" b="1">
@@ -14330,7 +14330,7 @@
               <a:rPr sz="1500">
                 <a:latin typeface="Arial"/>
               </a:rPr>
-              <a:t>12. Identificacao e sugestao de correção de erros — 3.3.1 (A / AA): </a:t>
+              <a:t>12. Identificação e sugestão de correção de erros — 3.3.1 (A / AA): </a:t>
             </a:r>
             <a:r>
               <a:rPr sz="1500" b="1">

</xml_diff>